<commit_message>
Updated images, presentation, readme
</commit_message>
<xml_diff>
--- a/presentation/Healthcare Duplicate MRN Continuous Improvement Analysis.pptx
+++ b/presentation/Healthcare Duplicate MRN Continuous Improvement Analysis.pptx
@@ -204,7 +204,7 @@
           <a:p>
             <a:fld id="{6DDFC07B-46B5-40A7-B02D-48D2AC2BB881}" type="datetimeFigureOut">
               <a:rPr lang="en-US" smtClean="0"/>
-              <a:t>7/4/2026</a:t>
+              <a:t>7/6/2026</a:t>
             </a:fld>
             <a:endParaRPr lang="en-US"/>
           </a:p>
@@ -7873,8 +7873,8 @@
         </p:nvSpPr>
         <p:spPr>
           <a:xfrm>
-            <a:off x="8087171" y="1706726"/>
-            <a:ext cx="3383280" cy="2560320"/>
+            <a:off x="8087171" y="1557641"/>
+            <a:ext cx="3383280" cy="2743200"/>
           </a:xfrm>
           <a:prstGeom prst="roundRect">
             <a:avLst/>
@@ -7977,8 +7977,8 @@
         </p:nvSpPr>
         <p:spPr>
           <a:xfrm>
-            <a:off x="4448556" y="1706726"/>
-            <a:ext cx="3383280" cy="2560320"/>
+            <a:off x="4448556" y="1557641"/>
+            <a:ext cx="3383280" cy="2743200"/>
           </a:xfrm>
           <a:prstGeom prst="roundRect">
             <a:avLst/>
@@ -8029,8 +8029,8 @@
         </p:nvSpPr>
         <p:spPr>
           <a:xfrm>
-            <a:off x="809941" y="1717351"/>
-            <a:ext cx="3383280" cy="2560320"/>
+            <a:off x="809941" y="1568266"/>
+            <a:ext cx="3383280" cy="2743200"/>
           </a:xfrm>
           <a:prstGeom prst="roundRect">
             <a:avLst/>
@@ -8085,7 +8085,7 @@
         </p:nvSpPr>
         <p:spPr>
           <a:xfrm>
-            <a:off x="2057400" y="272525"/>
+            <a:off x="2057400" y="153257"/>
             <a:ext cx="9296400" cy="1325563"/>
           </a:xfrm>
         </p:spPr>
@@ -8122,7 +8122,7 @@
         </p:nvSpPr>
         <p:spPr>
           <a:xfrm>
-            <a:off x="955968" y="1859521"/>
+            <a:off x="955968" y="1650802"/>
             <a:ext cx="3200400" cy="2157984"/>
           </a:xfrm>
         </p:spPr>
@@ -8209,7 +8209,7 @@
         </p:nvSpPr>
         <p:spPr>
           <a:xfrm>
-            <a:off x="4631436" y="1846074"/>
+            <a:off x="4631436" y="1637355"/>
             <a:ext cx="3200400" cy="2153593"/>
           </a:xfrm>
           <a:prstGeom prst="rect">
@@ -8394,7 +8394,7 @@
                   <a:srgbClr val="1B491D"/>
                 </a:solidFill>
               </a:rPr>
-              <a:t>Reinforce Reliable Search Method</a:t>
+              <a:t>Reinforce Reliable Search Method (RSM)</a:t>
             </a:r>
           </a:p>
           <a:p>
@@ -8402,8 +8402,8 @@
               <a:buNone/>
             </a:pPr>
             <a:r>
-              <a:rPr lang="en-US" sz="1700" dirty="0"/>
-              <a:t>Send targeted email reminders and the Reliable Search Method guide to external providers with higher duplicate creation rates.</a:t>
+              <a:rPr lang="en-US" sz="1800" dirty="0"/>
+              <a:t>Reinforce the RSM for internal registration staff and external providers through refresher education and targeted reminders.</a:t>
             </a:r>
           </a:p>
           <a:p>
@@ -8900,7 +8900,7 @@
         </p:nvCxnSpPr>
         <p:spPr>
           <a:xfrm>
-            <a:off x="1338858" y="1538285"/>
+            <a:off x="1338858" y="1419017"/>
             <a:ext cx="9514285" cy="0"/>
           </a:xfrm>
           <a:prstGeom prst="line">
@@ -8955,7 +8955,7 @@
         </p:blipFill>
         <p:spPr>
           <a:xfrm>
-            <a:off x="1338858" y="639845"/>
+            <a:off x="1338858" y="520577"/>
             <a:ext cx="718542" cy="718542"/>
           </a:xfrm>
           <a:prstGeom prst="rect">
@@ -8977,7 +8977,7 @@
         </p:nvSpPr>
         <p:spPr>
           <a:xfrm>
-            <a:off x="2077656" y="1179542"/>
+            <a:off x="2077656" y="1060274"/>
             <a:ext cx="6489486" cy="307777"/>
           </a:xfrm>
           <a:prstGeom prst="rect">
@@ -9021,7 +9021,7 @@
         </p:nvSpPr>
         <p:spPr>
           <a:xfrm>
-            <a:off x="8206045" y="1859521"/>
+            <a:off x="8206045" y="1650802"/>
             <a:ext cx="3200400" cy="2153593"/>
           </a:xfrm>
           <a:prstGeom prst="rect">

</xml_diff>